<commit_message>
[ADD & Update] updated the CySec slides 1 to 7
Added missing slides and removed the workforms to allow students a much cleaner learning experience, teachers version still exists
</commit_message>
<xml_diff>
--- a/Lesmateriaal/Slides/CySec – les 2 - Algo hashing encryptie en beveiliging.pptx
+++ b/Lesmateriaal/Slides/CySec – les 2 - Algo hashing encryptie en beveiliging.pptx
@@ -217,7 +217,7 @@
           <a:p>
             <a:fld id="{F958DB6F-D407-4DAD-8E07-F71A85896F6E}" type="datetimeFigureOut">
               <a:rPr lang="nl-NL" smtClean="0"/>
-              <a:t>11-2-2026</a:t>
+              <a:t>7-3-2026</a:t>
             </a:fld>
             <a:endParaRPr lang="nl-NL"/>
           </a:p>
@@ -636,7 +636,7 @@
           <a:p>
             <a:fld id="{6D18414D-5A9A-49A8-AA48-E9E7CADEA260}" type="datetimeFigureOut">
               <a:rPr lang="nl-NL" smtClean="0"/>
-              <a:t>11-2-2026</a:t>
+              <a:t>7-3-2026</a:t>
             </a:fld>
             <a:endParaRPr lang="nl-NL"/>
           </a:p>
@@ -844,7 +844,7 @@
           <a:p>
             <a:fld id="{6D18414D-5A9A-49A8-AA48-E9E7CADEA260}" type="datetimeFigureOut">
               <a:rPr lang="nl-NL" smtClean="0"/>
-              <a:t>11-2-2026</a:t>
+              <a:t>7-3-2026</a:t>
             </a:fld>
             <a:endParaRPr lang="nl-NL"/>
           </a:p>
@@ -1053,7 +1053,7 @@
           <a:p>
             <a:fld id="{6D18414D-5A9A-49A8-AA48-E9E7CADEA260}" type="datetimeFigureOut">
               <a:rPr lang="nl-NL" smtClean="0"/>
-              <a:t>11-2-2026</a:t>
+              <a:t>7-3-2026</a:t>
             </a:fld>
             <a:endParaRPr lang="nl-NL"/>
           </a:p>
@@ -1251,7 +1251,7 @@
           <a:p>
             <a:fld id="{6D18414D-5A9A-49A8-AA48-E9E7CADEA260}" type="datetimeFigureOut">
               <a:rPr lang="nl-NL" smtClean="0"/>
-              <a:t>11-2-2026</a:t>
+              <a:t>7-3-2026</a:t>
             </a:fld>
             <a:endParaRPr lang="nl-NL"/>
           </a:p>
@@ -1526,7 +1526,7 @@
           <a:p>
             <a:fld id="{6D18414D-5A9A-49A8-AA48-E9E7CADEA260}" type="datetimeFigureOut">
               <a:rPr lang="nl-NL" smtClean="0"/>
-              <a:t>11-2-2026</a:t>
+              <a:t>7-3-2026</a:t>
             </a:fld>
             <a:endParaRPr lang="nl-NL"/>
           </a:p>
@@ -1791,7 +1791,7 @@
           <a:p>
             <a:fld id="{6D18414D-5A9A-49A8-AA48-E9E7CADEA260}" type="datetimeFigureOut">
               <a:rPr lang="nl-NL" smtClean="0"/>
-              <a:t>11-2-2026</a:t>
+              <a:t>7-3-2026</a:t>
             </a:fld>
             <a:endParaRPr lang="nl-NL"/>
           </a:p>
@@ -2204,7 +2204,7 @@
           <a:p>
             <a:fld id="{6D18414D-5A9A-49A8-AA48-E9E7CADEA260}" type="datetimeFigureOut">
               <a:rPr lang="nl-NL" smtClean="0"/>
-              <a:t>11-2-2026</a:t>
+              <a:t>7-3-2026</a:t>
             </a:fld>
             <a:endParaRPr lang="nl-NL"/>
           </a:p>
@@ -2345,7 +2345,7 @@
           <a:p>
             <a:fld id="{6D18414D-5A9A-49A8-AA48-E9E7CADEA260}" type="datetimeFigureOut">
               <a:rPr lang="nl-NL" smtClean="0"/>
-              <a:t>11-2-2026</a:t>
+              <a:t>7-3-2026</a:t>
             </a:fld>
             <a:endParaRPr lang="nl-NL"/>
           </a:p>
@@ -2458,7 +2458,7 @@
           <a:p>
             <a:fld id="{6D18414D-5A9A-49A8-AA48-E9E7CADEA260}" type="datetimeFigureOut">
               <a:rPr lang="nl-NL" smtClean="0"/>
-              <a:t>11-2-2026</a:t>
+              <a:t>7-3-2026</a:t>
             </a:fld>
             <a:endParaRPr lang="nl-NL"/>
           </a:p>
@@ -2769,7 +2769,7 @@
           <a:p>
             <a:fld id="{6D18414D-5A9A-49A8-AA48-E9E7CADEA260}" type="datetimeFigureOut">
               <a:rPr lang="nl-NL" smtClean="0"/>
-              <a:t>11-2-2026</a:t>
+              <a:t>7-3-2026</a:t>
             </a:fld>
             <a:endParaRPr lang="nl-NL"/>
           </a:p>
@@ -3060,7 +3060,7 @@
           <a:p>
             <a:fld id="{6D18414D-5A9A-49A8-AA48-E9E7CADEA260}" type="datetimeFigureOut">
               <a:rPr lang="nl-NL" smtClean="0"/>
-              <a:t>11-2-2026</a:t>
+              <a:t>7-3-2026</a:t>
             </a:fld>
             <a:endParaRPr lang="nl-NL"/>
           </a:p>
@@ -3252,7 +3252,7 @@
           <a:p>
             <a:fld id="{6D18414D-5A9A-49A8-AA48-E9E7CADEA260}" type="datetimeFigureOut">
               <a:rPr lang="nl-NL" smtClean="0"/>
-              <a:t>11-2-2026</a:t>
+              <a:t>7-3-2026</a:t>
             </a:fld>
             <a:endParaRPr lang="nl-NL" dirty="0"/>
           </a:p>
@@ -4710,7 +4710,7 @@
             </a:r>
             <a:r>
               <a:rPr lang="nl-NL" dirty="0"/>
-              <a:t> is </a:t>
+              <a:t> is NIET </a:t>
             </a:r>
             <a:r>
               <a:rPr lang="nl-NL" dirty="0" err="1"/>
@@ -5139,13 +5139,8 @@
             </a:r>
             <a:r>
               <a:rPr lang="nl-NL" dirty="0"/>
-              <a:t> </a:t>
-            </a:r>
-            <a:r>
-              <a:rPr lang="nl-NL" dirty="0" err="1"/>
-              <a:t>exncryptie</a:t>
-            </a:r>
-            <a:endParaRPr lang="nl-NL" dirty="0"/>
+              <a:t> encryptie</a:t>
+            </a:r>
           </a:p>
           <a:p>
             <a:r>

</xml_diff>